<commit_message>
Add the Module 4 slides
Two slides, because the result has two halves and only showing the first
would be a sales pitch. Slide 11 is H3 -- citation support 0.162
closed-book against 0.826 with fusion, on identical questions with an
identical generator. Slide 12 is the decomposition that qualifies it:
retrieval error 0.193, generation error 0.597, so our own contribution
improves the smaller of the two.

The cut list names 12 as the one never to drop, which needed fixing
after renumbering moved it into the position the old list said to cut.

Deck is 16 slides for about 14 minutes.
</commit_message>
<xml_diff>
--- a/paper/IndicRAG-QA-slides.pptx
+++ b/paper/IndicRAG-QA-slides.pptx
@@ -19,6 +19,8 @@
     <p:sldId id="267" r:id="rId19"/>
     <p:sldId id="268" r:id="rId20"/>
     <p:sldId id="269" r:id="rId21"/>
+    <p:sldId id="270" r:id="rId22"/>
+    <p:sldId id="271" r:id="rId23"/>
   </p:sldIdLst>
   <p:sldSz cx="12191695" cy="6858000" type="screen4x3"/>
   <p:notesSz cx="6858000" cy="9144000"/>
@@ -655,7 +657,7 @@
           <a:lstStyle/>
           <a:p>
             <a:r>
-              <a:t>Two retrievers of equal accuracy can combine well or destructively depending on whether each could have retrieved what the other did.</a:t>
+              <a:t>This is H3 and it is the cleanest result in the deck. The closed-book arm is not refusing — it is confidently reciting eligibility thresholds from memory and getting them wrong.</a:t>
             </a:r>
           </a:p>
         </p:txBody>
@@ -725,7 +727,7 @@
           <a:lstStyle/>
           <a:p>
             <a:r>
-              <a:t>A property of the signal, not the calibration. The fitted operating point swings from 0.000 recall to 0.93 depending only on the split, while the curve underneath stays flat — which is why the separation table matters more than any single number. Motivates the NLI signal.</a:t>
+              <a:t>The slide that stops the talk being a sales pitch. The fusion result is a claim about retrieval, measured as retrieval. It is not a claim that retrieval is what limits answer quality here. This ratio is a property of a 3B quantized model, not a law — but it is why the oracle arm exists.</a:t>
             </a:r>
           </a:p>
         </p:txBody>
@@ -795,7 +797,7 @@
           <a:lstStyle/>
           <a:p>
             <a:r>
-              <a:t>Say these before the Q&amp;A rather than during it.</a:t>
+              <a:t>Two retrievers of equal accuracy can combine well or destructively depending on whether each could have retrieved what the other did.</a:t>
             </a:r>
           </a:p>
         </p:txBody>
@@ -821,6 +823,146 @@
 </file>
 
 <file path=ppt/notesSlides/notesSlide14.xml><?xml version="1.0" encoding="utf-8"?>
+<p:notes xmlns:a="http://schemas.openxmlformats.org/drawingml/2006/main" xmlns:p="http://schemas.openxmlformats.org/presentationml/2006/main" xmlns:r="http://schemas.openxmlformats.org/officeDocument/2006/relationships">
+  <p:cSld>
+    <p:spTree>
+      <p:nvGrpSpPr>
+        <p:cNvPr id="1" name=""/>
+        <p:cNvGrpSpPr/>
+        <p:nvPr/>
+      </p:nvGrpSpPr>
+      <p:grpSpPr>
+        <a:xfrm>
+          <a:off x="0" y="0"/>
+          <a:ext cx="0" cy="0"/>
+          <a:chOff x="0" y="0"/>
+          <a:chExt cx="0" cy="0"/>
+        </a:xfrm>
+      </p:grpSpPr>
+      <p:sp>
+        <p:nvSpPr>
+          <p:cNvPr id="2" name="Slide Image Placeholder 1"/>
+          <p:cNvSpPr>
+            <a:spLocks noGrp="1"/>
+          </p:cNvSpPr>
+          <p:nvPr>
+            <p:ph type="sldImg" idx="2"/>
+          </p:nvPr>
+        </p:nvSpPr>
+        <p:spPr/>
+      </p:sp>
+      <p:sp>
+        <p:nvSpPr>
+          <p:cNvPr id="3" name="Notes Placeholder 2"/>
+          <p:cNvSpPr>
+            <a:spLocks noGrp="1"/>
+          </p:cNvSpPr>
+          <p:nvPr>
+            <p:ph type="body" idx="3" sz="quarter"/>
+          </p:nvPr>
+        </p:nvSpPr>
+        <p:spPr/>
+        <p:txBody>
+          <a:bodyPr/>
+          <a:lstStyle/>
+          <a:p>
+            <a:r>
+              <a:t>A property of the signal, not the calibration. The fitted operating point swings from 0.000 recall to 0.93 depending only on the split, while the curve underneath stays flat — which is why the separation table matters more than any single number. Motivates the NLI signal.</a:t>
+            </a:r>
+          </a:p>
+        </p:txBody>
+      </p:sp>
+      <p:sp>
+        <p:nvSpPr>
+          <p:cNvPr id="4" name="Slide Number Placeholder 3"/>
+          <p:cNvSpPr>
+            <a:spLocks noGrp="1"/>
+          </p:cNvSpPr>
+          <p:nvPr>
+            <p:ph type="sldNum" idx="5" sz="quarter"/>
+          </p:nvPr>
+        </p:nvSpPr>
+        <p:spPr/>
+      </p:sp>
+    </p:spTree>
+  </p:cSld>
+  <p:clrMapOvr>
+    <a:masterClrMapping/>
+  </p:clrMapOvr>
+</p:notes>
+</file>
+
+<file path=ppt/notesSlides/notesSlide15.xml><?xml version="1.0" encoding="utf-8"?>
+<p:notes xmlns:a="http://schemas.openxmlformats.org/drawingml/2006/main" xmlns:p="http://schemas.openxmlformats.org/presentationml/2006/main" xmlns:r="http://schemas.openxmlformats.org/officeDocument/2006/relationships">
+  <p:cSld>
+    <p:spTree>
+      <p:nvGrpSpPr>
+        <p:cNvPr id="1" name=""/>
+        <p:cNvGrpSpPr/>
+        <p:nvPr/>
+      </p:nvGrpSpPr>
+      <p:grpSpPr>
+        <a:xfrm>
+          <a:off x="0" y="0"/>
+          <a:ext cx="0" cy="0"/>
+          <a:chOff x="0" y="0"/>
+          <a:chExt cx="0" cy="0"/>
+        </a:xfrm>
+      </p:grpSpPr>
+      <p:sp>
+        <p:nvSpPr>
+          <p:cNvPr id="2" name="Slide Image Placeholder 1"/>
+          <p:cNvSpPr>
+            <a:spLocks noGrp="1"/>
+          </p:cNvSpPr>
+          <p:nvPr>
+            <p:ph type="sldImg" idx="2"/>
+          </p:nvPr>
+        </p:nvSpPr>
+        <p:spPr/>
+      </p:sp>
+      <p:sp>
+        <p:nvSpPr>
+          <p:cNvPr id="3" name="Notes Placeholder 2"/>
+          <p:cNvSpPr>
+            <a:spLocks noGrp="1"/>
+          </p:cNvSpPr>
+          <p:nvPr>
+            <p:ph type="body" idx="3" sz="quarter"/>
+          </p:nvPr>
+        </p:nvSpPr>
+        <p:spPr/>
+        <p:txBody>
+          <a:bodyPr/>
+          <a:lstStyle/>
+          <a:p>
+            <a:r>
+              <a:t>Say these before the Q&amp;A rather than during it.</a:t>
+            </a:r>
+          </a:p>
+        </p:txBody>
+      </p:sp>
+      <p:sp>
+        <p:nvSpPr>
+          <p:cNvPr id="4" name="Slide Number Placeholder 3"/>
+          <p:cNvSpPr>
+            <a:spLocks noGrp="1"/>
+          </p:cNvSpPr>
+          <p:nvPr>
+            <p:ph type="sldNum" idx="5" sz="quarter"/>
+          </p:nvPr>
+        </p:nvSpPr>
+        <p:spPr/>
+      </p:sp>
+    </p:spTree>
+  </p:cSld>
+  <p:clrMapOvr>
+    <a:masterClrMapping/>
+  </p:clrMapOvr>
+</p:notes>
+</file>
+
+<file path=ppt/notesSlides/notesSlide16.xml><?xml version="1.0" encoding="utf-8"?>
 <p:notes xmlns:a="http://schemas.openxmlformats.org/drawingml/2006/main" xmlns:p="http://schemas.openxmlformats.org/presentationml/2006/main" xmlns:r="http://schemas.openxmlformats.org/officeDocument/2006/relationships">
   <p:cSld>
     <p:spTree>
@@ -4815,7 +4957,7 @@
                 </a:solidFill>
                 <a:latin typeface="Calibri"/>
               </a:rPr>
-              <a:t>Where this generalises</a:t>
+              <a:t>Does it actually help the answers?</a:t>
             </a:r>
           </a:p>
         </p:txBody>
@@ -4854,7 +4996,7 @@
                 </a:solidFill>
                 <a:latin typeface="Calibri"/>
               </a:rPr>
-              <a:t>Not about Hindi. Not about script.</a:t>
+              <a:t>Four arms, same generator, differing only in the evidence given.</a:t>
             </a:r>
           </a:p>
           <a:p>
@@ -4870,7 +5012,7 @@
                 </a:solidFill>
                 <a:latin typeface="Calibri"/>
               </a:rPr>
-              <a:t>Anywhere rank fusion runs over retrievers with asymmetric coverage:</a:t>
+              <a:t>Closed-book answers 37 of 72 questions. 16% of those answers are supported</a:t>
             </a:r>
           </a:p>
           <a:p>
@@ -4886,7 +5028,7 @@
                 </a:solidFill>
                 <a:latin typeface="Calibri"/>
               </a:rPr>
-              <a:t>- text × image/table retrieval — each blind to the other's modality</a:t>
+              <a:t>by the evidence.</a:t>
             </a:r>
           </a:p>
           <a:p>
@@ -4902,7 +5044,7 @@
                 </a:solidFill>
                 <a:latin typeface="Calibri"/>
               </a:rPr>
-              <a:t>- access-controlled shards — one retriever permitted a subset</a:t>
+              <a:t>Script-aware fusion propagates: hybrid beats dense on support and abstains</a:t>
             </a:r>
           </a:p>
           <a:p>
@@ -4918,30 +5060,412 @@
                 </a:solidFill>
                 <a:latin typeface="Calibri"/>
               </a:rPr>
-              <a:t>- specialist × general index over partly-covered collections</a:t>
-            </a:r>
-          </a:p>
-          <a:p>
-            <a:pPr>
-              <a:spcAft>
-                <a:spcPts val="600"/>
-              </a:spcAft>
-            </a:pPr>
-            <a:r>
-              <a:rPr sz="1800" b="0">
-                <a:solidFill>
-                  <a:srgbClr val="1A1A1A"/>
-                </a:solidFill>
-                <a:latin typeface="Calibri"/>
-              </a:rPr>
-              <a:t>Guidance: before fusing, check retriever coverage, not only quality.</a:t>
-            </a:r>
-          </a:p>
-        </p:txBody>
-      </p:sp>
-      <p:sp>
-        <p:nvSpPr>
-          <p:cNvPr id="4" name="TextBox 3"/>
+              <a:t>less, same model, same questions.</a:t>
+            </a:r>
+          </a:p>
+        </p:txBody>
+      </p:sp>
+      <p:graphicFrame>
+        <p:nvGraphicFramePr>
+          <p:cNvPr id="4" name="Table 3"/>
+          <p:cNvGraphicFramePr>
+            <a:graphicFrameLocks noGrp="1"/>
+          </p:cNvGraphicFramePr>
+          <p:nvPr/>
+        </p:nvGraphicFramePr>
+        <p:xfrm>
+          <a:off x="640080" y="3383280"/>
+          <a:ext cx="10058400" cy="1463040"/>
+        </p:xfrm>
+        <a:graphic>
+          <a:graphicData uri="http://schemas.openxmlformats.org/drawingml/2006/table">
+            <a:tbl>
+              <a:tblPr firstRow="1" bandRow="1">
+                <a:tableStyleId>{5C22544A-7EE6-4342-B048-85BDC9FD1C3A}</a:tableStyleId>
+              </a:tblPr>
+              <a:tblGrid>
+                <a:gridCol w="2514600"/>
+                <a:gridCol w="2514600"/>
+                <a:gridCol w="2514600"/>
+                <a:gridCol w="2514600"/>
+              </a:tblGrid>
+              <a:tr h="292608">
+                <a:tc>
+                  <a:txBody>
+                    <a:bodyPr/>
+                    <a:lstStyle/>
+                    <a:p>
+                      <a:r>
+                        <a:rPr sz="1300" b="1">
+                          <a:solidFill>
+                            <a:srgbClr val="1A1A1A"/>
+                          </a:solidFill>
+                          <a:latin typeface="Calibri"/>
+                        </a:rPr>
+                        <a:t>Arm</a:t>
+                      </a:r>
+                    </a:p>
+                  </a:txBody>
+                  <a:tcPr/>
+                </a:tc>
+                <a:tc>
+                  <a:txBody>
+                    <a:bodyPr/>
+                    <a:lstStyle/>
+                    <a:p>
+                      <a:r>
+                        <a:rPr sz="1300" b="1">
+                          <a:solidFill>
+                            <a:srgbClr val="1A1A1A"/>
+                          </a:solidFill>
+                          <a:latin typeface="Calibri"/>
+                        </a:rPr>
+                        <a:t>token-F1</a:t>
+                      </a:r>
+                    </a:p>
+                  </a:txBody>
+                  <a:tcPr/>
+                </a:tc>
+                <a:tc>
+                  <a:txBody>
+                    <a:bodyPr/>
+                    <a:lstStyle/>
+                    <a:p>
+                      <a:r>
+                        <a:rPr sz="1300" b="1">
+                          <a:solidFill>
+                            <a:srgbClr val="1A1A1A"/>
+                          </a:solidFill>
+                          <a:latin typeface="Calibri"/>
+                        </a:rPr>
+                        <a:t>abstains</a:t>
+                      </a:r>
+                    </a:p>
+                  </a:txBody>
+                  <a:tcPr/>
+                </a:tc>
+                <a:tc>
+                  <a:txBody>
+                    <a:bodyPr/>
+                    <a:lstStyle/>
+                    <a:p>
+                      <a:r>
+                        <a:rPr sz="1300" b="1">
+                          <a:solidFill>
+                            <a:srgbClr val="1A1A1A"/>
+                          </a:solidFill>
+                          <a:latin typeface="Calibri"/>
+                        </a:rPr>
+                        <a:t>Citation Support</a:t>
+                      </a:r>
+                    </a:p>
+                  </a:txBody>
+                  <a:tcPr/>
+                </a:tc>
+              </a:tr>
+              <a:tr h="292608">
+                <a:tc>
+                  <a:txBody>
+                    <a:bodyPr/>
+                    <a:lstStyle/>
+                    <a:p>
+                      <a:r>
+                        <a:rPr sz="1300" b="0">
+                          <a:solidFill>
+                            <a:srgbClr val="1A1A1A"/>
+                          </a:solidFill>
+                          <a:latin typeface="Calibri"/>
+                        </a:rPr>
+                        <a:t>closed-book</a:t>
+                      </a:r>
+                    </a:p>
+                  </a:txBody>
+                  <a:tcPr/>
+                </a:tc>
+                <a:tc>
+                  <a:txBody>
+                    <a:bodyPr/>
+                    <a:lstStyle/>
+                    <a:p>
+                      <a:r>
+                        <a:rPr sz="1300" b="0">
+                          <a:solidFill>
+                            <a:srgbClr val="1A1A1A"/>
+                          </a:solidFill>
+                          <a:latin typeface="Calibri"/>
+                        </a:rPr>
+                        <a:t>0.065</a:t>
+                      </a:r>
+                    </a:p>
+                  </a:txBody>
+                  <a:tcPr/>
+                </a:tc>
+                <a:tc>
+                  <a:txBody>
+                    <a:bodyPr/>
+                    <a:lstStyle/>
+                    <a:p>
+                      <a:r>
+                        <a:rPr sz="1300" b="0">
+                          <a:solidFill>
+                            <a:srgbClr val="1A1A1A"/>
+                          </a:solidFill>
+                          <a:latin typeface="Calibri"/>
+                        </a:rPr>
+                        <a:t>0.486</a:t>
+                      </a:r>
+                    </a:p>
+                  </a:txBody>
+                  <a:tcPr/>
+                </a:tc>
+                <a:tc>
+                  <a:txBody>
+                    <a:bodyPr/>
+                    <a:lstStyle/>
+                    <a:p>
+                      <a:r>
+                        <a:rPr sz="1300" b="0">
+                          <a:solidFill>
+                            <a:srgbClr val="1A1A1A"/>
+                          </a:solidFill>
+                          <a:latin typeface="Calibri"/>
+                        </a:rPr>
+                        <a:t>0.162</a:t>
+                      </a:r>
+                    </a:p>
+                  </a:txBody>
+                  <a:tcPr/>
+                </a:tc>
+              </a:tr>
+              <a:tr h="292608">
+                <a:tc>
+                  <a:txBody>
+                    <a:bodyPr/>
+                    <a:lstStyle/>
+                    <a:p>
+                      <a:r>
+                        <a:rPr sz="1300" b="0">
+                          <a:solidFill>
+                            <a:srgbClr val="1A1A1A"/>
+                          </a:solidFill>
+                          <a:latin typeface="Calibri"/>
+                        </a:rPr>
+                        <a:t>RAG dense</a:t>
+                      </a:r>
+                    </a:p>
+                  </a:txBody>
+                  <a:tcPr/>
+                </a:tc>
+                <a:tc>
+                  <a:txBody>
+                    <a:bodyPr/>
+                    <a:lstStyle/>
+                    <a:p>
+                      <a:r>
+                        <a:rPr sz="1300" b="0">
+                          <a:solidFill>
+                            <a:srgbClr val="1A1A1A"/>
+                          </a:solidFill>
+                          <a:latin typeface="Calibri"/>
+                        </a:rPr>
+                        <a:t>0.207</a:t>
+                      </a:r>
+                    </a:p>
+                  </a:txBody>
+                  <a:tcPr/>
+                </a:tc>
+                <a:tc>
+                  <a:txBody>
+                    <a:bodyPr/>
+                    <a:lstStyle/>
+                    <a:p>
+                      <a:r>
+                        <a:rPr sz="1300" b="0">
+                          <a:solidFill>
+                            <a:srgbClr val="1A1A1A"/>
+                          </a:solidFill>
+                          <a:latin typeface="Calibri"/>
+                        </a:rPr>
+                        <a:t>0.417</a:t>
+                      </a:r>
+                    </a:p>
+                  </a:txBody>
+                  <a:tcPr/>
+                </a:tc>
+                <a:tc>
+                  <a:txBody>
+                    <a:bodyPr/>
+                    <a:lstStyle/>
+                    <a:p>
+                      <a:r>
+                        <a:rPr sz="1300" b="0">
+                          <a:solidFill>
+                            <a:srgbClr val="1A1A1A"/>
+                          </a:solidFill>
+                          <a:latin typeface="Calibri"/>
+                        </a:rPr>
+                        <a:t>0.762</a:t>
+                      </a:r>
+                    </a:p>
+                  </a:txBody>
+                  <a:tcPr/>
+                </a:tc>
+              </a:tr>
+              <a:tr h="292608">
+                <a:tc>
+                  <a:txBody>
+                    <a:bodyPr/>
+                    <a:lstStyle/>
+                    <a:p>
+                      <a:r>
+                        <a:rPr sz="1300" b="0">
+                          <a:solidFill>
+                            <a:srgbClr val="1A1A1A"/>
+                          </a:solidFill>
+                          <a:latin typeface="Calibri"/>
+                        </a:rPr>
+                        <a:t>RAG hybrid</a:t>
+                      </a:r>
+                    </a:p>
+                  </a:txBody>
+                  <a:tcPr/>
+                </a:tc>
+                <a:tc>
+                  <a:txBody>
+                    <a:bodyPr/>
+                    <a:lstStyle/>
+                    <a:p>
+                      <a:r>
+                        <a:rPr sz="1300" b="0">
+                          <a:solidFill>
+                            <a:srgbClr val="1A1A1A"/>
+                          </a:solidFill>
+                          <a:latin typeface="Calibri"/>
+                        </a:rPr>
+                        <a:t>0.210</a:t>
+                      </a:r>
+                    </a:p>
+                  </a:txBody>
+                  <a:tcPr/>
+                </a:tc>
+                <a:tc>
+                  <a:txBody>
+                    <a:bodyPr/>
+                    <a:lstStyle/>
+                    <a:p>
+                      <a:r>
+                        <a:rPr sz="1300" b="0">
+                          <a:solidFill>
+                            <a:srgbClr val="1A1A1A"/>
+                          </a:solidFill>
+                          <a:latin typeface="Calibri"/>
+                        </a:rPr>
+                        <a:t>0.361</a:t>
+                      </a:r>
+                    </a:p>
+                  </a:txBody>
+                  <a:tcPr/>
+                </a:tc>
+                <a:tc>
+                  <a:txBody>
+                    <a:bodyPr/>
+                    <a:lstStyle/>
+                    <a:p>
+                      <a:r>
+                        <a:rPr sz="1300" b="0">
+                          <a:solidFill>
+                            <a:srgbClr val="1A1A1A"/>
+                          </a:solidFill>
+                          <a:latin typeface="Calibri"/>
+                        </a:rPr>
+                        <a:t>0.826</a:t>
+                      </a:r>
+                    </a:p>
+                  </a:txBody>
+                  <a:tcPr/>
+                </a:tc>
+              </a:tr>
+              <a:tr h="292608">
+                <a:tc>
+                  <a:txBody>
+                    <a:bodyPr/>
+                    <a:lstStyle/>
+                    <a:p>
+                      <a:r>
+                        <a:rPr sz="1300" b="0">
+                          <a:solidFill>
+                            <a:srgbClr val="1A1A1A"/>
+                          </a:solidFill>
+                          <a:latin typeface="Calibri"/>
+                        </a:rPr>
+                        <a:t>oracle</a:t>
+                      </a:r>
+                    </a:p>
+                  </a:txBody>
+                  <a:tcPr/>
+                </a:tc>
+                <a:tc>
+                  <a:txBody>
+                    <a:bodyPr/>
+                    <a:lstStyle/>
+                    <a:p>
+                      <a:r>
+                        <a:rPr sz="1300" b="0">
+                          <a:solidFill>
+                            <a:srgbClr val="1A1A1A"/>
+                          </a:solidFill>
+                          <a:latin typeface="Calibri"/>
+                        </a:rPr>
+                        <a:t>0.403</a:t>
+                      </a:r>
+                    </a:p>
+                  </a:txBody>
+                  <a:tcPr/>
+                </a:tc>
+                <a:tc>
+                  <a:txBody>
+                    <a:bodyPr/>
+                    <a:lstStyle/>
+                    <a:p>
+                      <a:r>
+                        <a:rPr sz="1300" b="0">
+                          <a:solidFill>
+                            <a:srgbClr val="1A1A1A"/>
+                          </a:solidFill>
+                          <a:latin typeface="Calibri"/>
+                        </a:rPr>
+                        <a:t>0.194</a:t>
+                      </a:r>
+                    </a:p>
+                  </a:txBody>
+                  <a:tcPr/>
+                </a:tc>
+                <a:tc>
+                  <a:txBody>
+                    <a:bodyPr/>
+                    <a:lstStyle/>
+                    <a:p>
+                      <a:r>
+                        <a:rPr sz="1300" b="0">
+                          <a:solidFill>
+                            <a:srgbClr val="1A1A1A"/>
+                          </a:solidFill>
+                          <a:latin typeface="Calibri"/>
+                        </a:rPr>
+                        <a:t>0.948</a:t>
+                      </a:r>
+                    </a:p>
+                  </a:txBody>
+                  <a:tcPr/>
+                </a:tc>
+              </a:tr>
+            </a:tbl>
+          </a:graphicData>
+        </a:graphic>
+      </p:graphicFrame>
+      <p:sp>
+        <p:nvSpPr>
+          <p:cNvPr id="5" name="TextBox 4"/>
           <p:cNvSpPr txBox="1"/>
           <p:nvPr/>
         </p:nvSpPr>
@@ -4987,6 +5511,550 @@
 </file>
 
 <file path=ppt/slides/slide12.xml><?xml version="1.0" encoding="utf-8"?>
+<p:sld xmlns:a="http://schemas.openxmlformats.org/drawingml/2006/main" xmlns:p="http://schemas.openxmlformats.org/presentationml/2006/main" xmlns:r="http://schemas.openxmlformats.org/officeDocument/2006/relationships">
+  <p:cSld>
+    <p:spTree>
+      <p:nvGrpSpPr>
+        <p:cNvPr id="1" name=""/>
+        <p:cNvGrpSpPr/>
+        <p:nvPr/>
+      </p:nvGrpSpPr>
+      <p:grpSpPr/>
+      <p:sp>
+        <p:nvSpPr>
+          <p:cNvPr id="2" name="TextBox 1"/>
+          <p:cNvSpPr txBox="1"/>
+          <p:nvPr/>
+        </p:nvSpPr>
+        <p:spPr>
+          <a:xfrm>
+            <a:off x="640080" y="457200"/>
+            <a:ext cx="10972800" cy="914400"/>
+          </a:xfrm>
+          <a:prstGeom prst="rect">
+            <a:avLst/>
+          </a:prstGeom>
+          <a:noFill/>
+        </p:spPr>
+        <p:txBody>
+          <a:bodyPr wrap="square">
+            <a:spAutoFit/>
+          </a:bodyPr>
+          <a:lstStyle/>
+          <a:p>
+            <a:pPr>
+              <a:spcAft>
+                <a:spcPts val="600"/>
+              </a:spcAft>
+            </a:pPr>
+            <a:r>
+              <a:rPr sz="2800" b="1">
+                <a:solidFill>
+                  <a:srgbClr val="1A1A1A"/>
+                </a:solidFill>
+                <a:latin typeface="Calibri"/>
+              </a:rPr>
+              <a:t>But retrieval is not the bottleneck</a:t>
+            </a:r>
+          </a:p>
+        </p:txBody>
+      </p:sp>
+      <p:sp>
+        <p:nvSpPr>
+          <p:cNvPr id="3" name="TextBox 2"/>
+          <p:cNvSpPr txBox="1"/>
+          <p:nvPr/>
+        </p:nvSpPr>
+        <p:spPr>
+          <a:xfrm>
+            <a:off x="640080" y="1463040"/>
+            <a:ext cx="10972800" cy="3108960"/>
+          </a:xfrm>
+          <a:prstGeom prst="rect">
+            <a:avLst/>
+          </a:prstGeom>
+          <a:noFill/>
+        </p:spPr>
+        <p:txBody>
+          <a:bodyPr wrap="square">
+            <a:spAutoFit/>
+          </a:bodyPr>
+          <a:lstStyle/>
+          <a:p>
+            <a:pPr>
+              <a:spcAft>
+                <a:spcPts val="600"/>
+              </a:spcAft>
+            </a:pPr>
+            <a:r>
+              <a:rPr sz="1800" b="0">
+                <a:solidFill>
+                  <a:srgbClr val="1A1A1A"/>
+                </a:solidFill>
+                <a:latin typeface="Calibri"/>
+              </a:rPr>
+              <a:t>Fixing retrieval entirely buys 0.193. The 3B generator is losing 0.597.</a:t>
+            </a:r>
+          </a:p>
+          <a:p>
+            <a:pPr>
+              <a:spcAft>
+                <a:spcPts val="600"/>
+              </a:spcAft>
+            </a:pPr>
+            <a:r>
+              <a:rPr sz="1800" b="0">
+                <a:solidFill>
+                  <a:srgbClr val="1A1A1A"/>
+                </a:solidFill>
+                <a:latin typeface="Calibri"/>
+              </a:rPr>
+              <a:t>Say this out loud: our own contribution improves the smaller of the two.</a:t>
+            </a:r>
+          </a:p>
+        </p:txBody>
+      </p:sp>
+      <p:graphicFrame>
+        <p:nvGraphicFramePr>
+          <p:cNvPr id="4" name="Table 3"/>
+          <p:cNvGraphicFramePr>
+            <a:graphicFrameLocks noGrp="1"/>
+          </p:cNvGraphicFramePr>
+          <p:nvPr/>
+        </p:nvGraphicFramePr>
+        <p:xfrm>
+          <a:off x="640080" y="2231136"/>
+          <a:ext cx="10058400" cy="1170432"/>
+        </p:xfrm>
+        <a:graphic>
+          <a:graphicData uri="http://schemas.openxmlformats.org/drawingml/2006/table">
+            <a:tbl>
+              <a:tblPr firstRow="1" bandRow="1">
+                <a:tableStyleId>{5C22544A-7EE6-4342-B048-85BDC9FD1C3A}</a:tableStyleId>
+              </a:tblPr>
+              <a:tblGrid>
+                <a:gridCol w="5029200"/>
+                <a:gridCol w="5029200"/>
+              </a:tblGrid>
+              <a:tr h="292608">
+                <a:tc>
+                  <a:txBody>
+                    <a:bodyPr/>
+                    <a:lstStyle/>
+                    <a:p>
+                      <a:r>
+                        <a:rPr sz="1300" b="1">
+                          <a:solidFill>
+                            <a:srgbClr val="1A1A1A"/>
+                          </a:solidFill>
+                          <a:latin typeface="Calibri"/>
+                        </a:rPr>
+                        <a:t>oracle token-F1</a:t>
+                      </a:r>
+                    </a:p>
+                  </a:txBody>
+                  <a:tcPr/>
+                </a:tc>
+                <a:tc>
+                  <a:txBody>
+                    <a:bodyPr/>
+                    <a:lstStyle/>
+                    <a:p>
+                      <a:r>
+                        <a:rPr sz="1300" b="1">
+                          <a:solidFill>
+                            <a:srgbClr val="1A1A1A"/>
+                          </a:solidFill>
+                          <a:latin typeface="Calibri"/>
+                        </a:rPr>
+                        <a:t>0.403</a:t>
+                      </a:r>
+                    </a:p>
+                  </a:txBody>
+                  <a:tcPr/>
+                </a:tc>
+              </a:tr>
+              <a:tr h="292608">
+                <a:tc>
+                  <a:txBody>
+                    <a:bodyPr/>
+                    <a:lstStyle/>
+                    <a:p>
+                      <a:r>
+                        <a:rPr sz="1300" b="0">
+                          <a:solidFill>
+                            <a:srgbClr val="1A1A1A"/>
+                          </a:solidFill>
+                          <a:latin typeface="Calibri"/>
+                        </a:rPr>
+                        <a:t>full system token-F1</a:t>
+                      </a:r>
+                    </a:p>
+                  </a:txBody>
+                  <a:tcPr/>
+                </a:tc>
+                <a:tc>
+                  <a:txBody>
+                    <a:bodyPr/>
+                    <a:lstStyle/>
+                    <a:p>
+                      <a:r>
+                        <a:rPr sz="1300" b="0">
+                          <a:solidFill>
+                            <a:srgbClr val="1A1A1A"/>
+                          </a:solidFill>
+                          <a:latin typeface="Calibri"/>
+                        </a:rPr>
+                        <a:t>0.210</a:t>
+                      </a:r>
+                    </a:p>
+                  </a:txBody>
+                  <a:tcPr/>
+                </a:tc>
+              </a:tr>
+              <a:tr h="292608">
+                <a:tc>
+                  <a:txBody>
+                    <a:bodyPr/>
+                    <a:lstStyle/>
+                    <a:p>
+                      <a:r>
+                        <a:rPr sz="1300" b="0">
+                          <a:solidFill>
+                            <a:srgbClr val="1A1A1A"/>
+                          </a:solidFill>
+                          <a:latin typeface="Calibri"/>
+                        </a:rPr>
+                        <a:t>retrieval error</a:t>
+                      </a:r>
+                    </a:p>
+                  </a:txBody>
+                  <a:tcPr/>
+                </a:tc>
+                <a:tc>
+                  <a:txBody>
+                    <a:bodyPr/>
+                    <a:lstStyle/>
+                    <a:p>
+                      <a:r>
+                        <a:rPr sz="1300" b="0">
+                          <a:solidFill>
+                            <a:srgbClr val="1A1A1A"/>
+                          </a:solidFill>
+                          <a:latin typeface="Calibri"/>
+                        </a:rPr>
+                        <a:t>0.193</a:t>
+                      </a:r>
+                    </a:p>
+                  </a:txBody>
+                  <a:tcPr/>
+                </a:tc>
+              </a:tr>
+              <a:tr h="292608">
+                <a:tc>
+                  <a:txBody>
+                    <a:bodyPr/>
+                    <a:lstStyle/>
+                    <a:p>
+                      <a:r>
+                        <a:rPr sz="1300" b="0">
+                          <a:solidFill>
+                            <a:srgbClr val="1A1A1A"/>
+                          </a:solidFill>
+                          <a:latin typeface="Calibri"/>
+                        </a:rPr>
+                        <a:t>generation error</a:t>
+                      </a:r>
+                    </a:p>
+                  </a:txBody>
+                  <a:tcPr/>
+                </a:tc>
+                <a:tc>
+                  <a:txBody>
+                    <a:bodyPr/>
+                    <a:lstStyle/>
+                    <a:p>
+                      <a:r>
+                        <a:rPr sz="1300" b="0">
+                          <a:solidFill>
+                            <a:srgbClr val="1A1A1A"/>
+                          </a:solidFill>
+                          <a:latin typeface="Calibri"/>
+                        </a:rPr>
+                        <a:t>0.597</a:t>
+                      </a:r>
+                    </a:p>
+                  </a:txBody>
+                  <a:tcPr/>
+                </a:tc>
+              </a:tr>
+            </a:tbl>
+          </a:graphicData>
+        </a:graphic>
+      </p:graphicFrame>
+      <p:sp>
+        <p:nvSpPr>
+          <p:cNvPr id="5" name="TextBox 4"/>
+          <p:cNvSpPr txBox="1"/>
+          <p:nvPr/>
+        </p:nvSpPr>
+        <p:spPr>
+          <a:xfrm>
+            <a:off x="11247120" y="6309360"/>
+            <a:ext cx="640080" cy="320040"/>
+          </a:xfrm>
+          <a:prstGeom prst="rect">
+            <a:avLst/>
+          </a:prstGeom>
+          <a:noFill/>
+        </p:spPr>
+        <p:txBody>
+          <a:bodyPr wrap="square">
+            <a:spAutoFit/>
+          </a:bodyPr>
+          <a:lstStyle/>
+          <a:p>
+            <a:pPr>
+              <a:spcAft>
+                <a:spcPts val="600"/>
+              </a:spcAft>
+            </a:pPr>
+            <a:r>
+              <a:rPr sz="1100" b="0">
+                <a:solidFill>
+                  <a:srgbClr val="5A5A5A"/>
+                </a:solidFill>
+                <a:latin typeface="Calibri"/>
+              </a:rPr>
+              <a:t>12</a:t>
+            </a:r>
+          </a:p>
+        </p:txBody>
+      </p:sp>
+    </p:spTree>
+  </p:cSld>
+  <p:clrMapOvr>
+    <a:masterClrMapping/>
+  </p:clrMapOvr>
+</p:sld>
+</file>
+
+<file path=ppt/slides/slide13.xml><?xml version="1.0" encoding="utf-8"?>
+<p:sld xmlns:a="http://schemas.openxmlformats.org/drawingml/2006/main" xmlns:p="http://schemas.openxmlformats.org/presentationml/2006/main" xmlns:r="http://schemas.openxmlformats.org/officeDocument/2006/relationships">
+  <p:cSld>
+    <p:spTree>
+      <p:nvGrpSpPr>
+        <p:cNvPr id="1" name=""/>
+        <p:cNvGrpSpPr/>
+        <p:nvPr/>
+      </p:nvGrpSpPr>
+      <p:grpSpPr/>
+      <p:sp>
+        <p:nvSpPr>
+          <p:cNvPr id="2" name="TextBox 1"/>
+          <p:cNvSpPr txBox="1"/>
+          <p:nvPr/>
+        </p:nvSpPr>
+        <p:spPr>
+          <a:xfrm>
+            <a:off x="640080" y="457200"/>
+            <a:ext cx="10972800" cy="914400"/>
+          </a:xfrm>
+          <a:prstGeom prst="rect">
+            <a:avLst/>
+          </a:prstGeom>
+          <a:noFill/>
+        </p:spPr>
+        <p:txBody>
+          <a:bodyPr wrap="square">
+            <a:spAutoFit/>
+          </a:bodyPr>
+          <a:lstStyle/>
+          <a:p>
+            <a:pPr>
+              <a:spcAft>
+                <a:spcPts val="600"/>
+              </a:spcAft>
+            </a:pPr>
+            <a:r>
+              <a:rPr sz="2800" b="1">
+                <a:solidFill>
+                  <a:srgbClr val="1A1A1A"/>
+                </a:solidFill>
+                <a:latin typeface="Calibri"/>
+              </a:rPr>
+              <a:t>Where this generalises</a:t>
+            </a:r>
+          </a:p>
+        </p:txBody>
+      </p:sp>
+      <p:sp>
+        <p:nvSpPr>
+          <p:cNvPr id="3" name="TextBox 2"/>
+          <p:cNvSpPr txBox="1"/>
+          <p:nvPr/>
+        </p:nvSpPr>
+        <p:spPr>
+          <a:xfrm>
+            <a:off x="640080" y="1463040"/>
+            <a:ext cx="10972800" cy="3108960"/>
+          </a:xfrm>
+          <a:prstGeom prst="rect">
+            <a:avLst/>
+          </a:prstGeom>
+          <a:noFill/>
+        </p:spPr>
+        <p:txBody>
+          <a:bodyPr wrap="square">
+            <a:spAutoFit/>
+          </a:bodyPr>
+          <a:lstStyle/>
+          <a:p>
+            <a:pPr>
+              <a:spcAft>
+                <a:spcPts val="600"/>
+              </a:spcAft>
+            </a:pPr>
+            <a:r>
+              <a:rPr sz="1800" b="0">
+                <a:solidFill>
+                  <a:srgbClr val="1A1A1A"/>
+                </a:solidFill>
+                <a:latin typeface="Calibri"/>
+              </a:rPr>
+              <a:t>Not about Hindi. Not about script.</a:t>
+            </a:r>
+          </a:p>
+          <a:p>
+            <a:pPr>
+              <a:spcAft>
+                <a:spcPts val="600"/>
+              </a:spcAft>
+            </a:pPr>
+            <a:r>
+              <a:rPr sz="1800" b="0">
+                <a:solidFill>
+                  <a:srgbClr val="1A1A1A"/>
+                </a:solidFill>
+                <a:latin typeface="Calibri"/>
+              </a:rPr>
+              <a:t>Anywhere rank fusion runs over retrievers with asymmetric coverage:</a:t>
+            </a:r>
+          </a:p>
+          <a:p>
+            <a:pPr>
+              <a:spcAft>
+                <a:spcPts val="600"/>
+              </a:spcAft>
+            </a:pPr>
+            <a:r>
+              <a:rPr sz="1800" b="0">
+                <a:solidFill>
+                  <a:srgbClr val="1A1A1A"/>
+                </a:solidFill>
+                <a:latin typeface="Calibri"/>
+              </a:rPr>
+              <a:t>- text × image/table retrieval — each blind to the other's modality</a:t>
+            </a:r>
+          </a:p>
+          <a:p>
+            <a:pPr>
+              <a:spcAft>
+                <a:spcPts val="600"/>
+              </a:spcAft>
+            </a:pPr>
+            <a:r>
+              <a:rPr sz="1800" b="0">
+                <a:solidFill>
+                  <a:srgbClr val="1A1A1A"/>
+                </a:solidFill>
+                <a:latin typeface="Calibri"/>
+              </a:rPr>
+              <a:t>- access-controlled shards — one retriever permitted a subset</a:t>
+            </a:r>
+          </a:p>
+          <a:p>
+            <a:pPr>
+              <a:spcAft>
+                <a:spcPts val="600"/>
+              </a:spcAft>
+            </a:pPr>
+            <a:r>
+              <a:rPr sz="1800" b="0">
+                <a:solidFill>
+                  <a:srgbClr val="1A1A1A"/>
+                </a:solidFill>
+                <a:latin typeface="Calibri"/>
+              </a:rPr>
+              <a:t>- specialist × general index over partly-covered collections</a:t>
+            </a:r>
+          </a:p>
+          <a:p>
+            <a:pPr>
+              <a:spcAft>
+                <a:spcPts val="600"/>
+              </a:spcAft>
+            </a:pPr>
+            <a:r>
+              <a:rPr sz="1800" b="0">
+                <a:solidFill>
+                  <a:srgbClr val="1A1A1A"/>
+                </a:solidFill>
+                <a:latin typeface="Calibri"/>
+              </a:rPr>
+              <a:t>Guidance: before fusing, check retriever coverage, not only quality.</a:t>
+            </a:r>
+          </a:p>
+        </p:txBody>
+      </p:sp>
+      <p:sp>
+        <p:nvSpPr>
+          <p:cNvPr id="4" name="TextBox 3"/>
+          <p:cNvSpPr txBox="1"/>
+          <p:nvPr/>
+        </p:nvSpPr>
+        <p:spPr>
+          <a:xfrm>
+            <a:off x="11247120" y="6309360"/>
+            <a:ext cx="640080" cy="320040"/>
+          </a:xfrm>
+          <a:prstGeom prst="rect">
+            <a:avLst/>
+          </a:prstGeom>
+          <a:noFill/>
+        </p:spPr>
+        <p:txBody>
+          <a:bodyPr wrap="square">
+            <a:spAutoFit/>
+          </a:bodyPr>
+          <a:lstStyle/>
+          <a:p>
+            <a:pPr>
+              <a:spcAft>
+                <a:spcPts val="600"/>
+              </a:spcAft>
+            </a:pPr>
+            <a:r>
+              <a:rPr sz="1100" b="0">
+                <a:solidFill>
+                  <a:srgbClr val="5A5A5A"/>
+                </a:solidFill>
+                <a:latin typeface="Calibri"/>
+              </a:rPr>
+              <a:t>13</a:t>
+            </a:r>
+          </a:p>
+        </p:txBody>
+      </p:sp>
+    </p:spTree>
+  </p:cSld>
+  <p:clrMapOvr>
+    <a:masterClrMapping/>
+  </p:clrMapOvr>
+</p:sld>
+</file>
+
+<file path=ppt/slides/slide14.xml><?xml version="1.0" encoding="utf-8"?>
 <p:sld xmlns:a="http://schemas.openxmlformats.org/drawingml/2006/main" xmlns:p="http://schemas.openxmlformats.org/presentationml/2006/main" xmlns:r="http://schemas.openxmlformats.org/officeDocument/2006/relationships">
   <p:cSld>
     <p:spTree>
@@ -5429,7 +6497,7 @@
                 </a:solidFill>
                 <a:latin typeface="Calibri"/>
               </a:rPr>
-              <a:t>12</a:t>
+              <a:t>14</a:t>
             </a:r>
           </a:p>
         </p:txBody>
@@ -5442,7 +6510,7 @@
 </p:sld>
 </file>
 
-<file path=ppt/slides/slide13.xml><?xml version="1.0" encoding="utf-8"?>
+<file path=ppt/slides/slide15.xml><?xml version="1.0" encoding="utf-8"?>
 <p:sld xmlns:a="http://schemas.openxmlformats.org/drawingml/2006/main" xmlns:p="http://schemas.openxmlformats.org/presentationml/2006/main" xmlns:r="http://schemas.openxmlformats.org/officeDocument/2006/relationships">
   <p:cSld>
     <p:spTree>
@@ -5628,7 +6696,7 @@
                 </a:solidFill>
                 <a:latin typeface="Calibri"/>
               </a:rPr>
-              <a:t>13</a:t>
+              <a:t>15</a:t>
             </a:r>
           </a:p>
         </p:txBody>
@@ -5641,7 +6709,7 @@
 </p:sld>
 </file>
 
-<file path=ppt/slides/slide14.xml><?xml version="1.0" encoding="utf-8"?>
+<file path=ppt/slides/slide16.xml><?xml version="1.0" encoding="utf-8"?>
 <p:sld xmlns:a="http://schemas.openxmlformats.org/drawingml/2006/main" xmlns:p="http://schemas.openxmlformats.org/presentationml/2006/main" xmlns:r="http://schemas.openxmlformats.org/officeDocument/2006/relationships">
   <p:cSld>
     <p:spTree>
@@ -5827,7 +6895,7 @@
                 </a:solidFill>
                 <a:latin typeface="Calibri"/>
               </a:rPr>
-              <a:t>14</a:t>
+              <a:t>16</a:t>
             </a:r>
           </a:p>
         </p:txBody>

</xml_diff>

<commit_message>
Rewrite the abstract on verified numbers; rebuild paper, PDF and slides
The abstract still quoted probe figures (0.022 -> 0.153) and a 400-item set,
under a drafting note. It now states the test-split result, the smaller gain
over dense alone, the BM25 abstention finding, and the model verification.
Contribution 3 claimed retrieval scores carry no answerability signal; the
verified set reversed that and it now says so, and what changed.

paper.md, the IEEE .docx and a new .pdf (Word's own export, figures
embedded) are rebuilt. The slides label the three that still rest on the
unverified Module 4 run, as the deck's own rule requires. README's
findings are rewritten from the test split.
</commit_message>
<xml_diff>
--- a/paper/IndicRAG-QA-slides.pptx
+++ b/paper/IndicRAG-QA-slides.pptx
@@ -1497,7 +1497,7 @@
           <a:lstStyle/>
           <a:p>
             <a:r>
-              <a:t>Read the monolingual row out loud. It is a real cost — removing the double vote loses precision where agreement genuinely was evidence.</a:t>
+              <a:t>Two comparisons, two answers. The repair to plain fusion is large and costs nothing monolingually. The gain over a good dense retriever is small — say so before someone asks.</a:t>
             </a:r>
           </a:p>
         </p:txBody>
@@ -1567,7 +1567,7 @@
           <a:lstStyle/>
           <a:p>
             <a:r>
-              <a:t>This is the slide that earns trust. Aggregates that conceal both the win and the cost are the default failure of results sections.</a:t>
+              <a:t>This is the slide that earns trust. The probe numbers were not wrong about the mechanism, only about the magnitudes.</a:t>
             </a:r>
           </a:p>
         </p:txBody>
@@ -5012,6 +5012,22 @@
                 </a:solidFill>
                 <a:latin typeface="Calibri"/>
               </a:rPr>
+              <a:t>Unverified items, 72-item sample — re-run on the test split pending.</a:t>
+            </a:r>
+          </a:p>
+          <a:p>
+            <a:pPr>
+              <a:spcAft>
+                <a:spcPts val="600"/>
+              </a:spcAft>
+            </a:pPr>
+            <a:r>
+              <a:rPr sz="1800" b="0">
+                <a:solidFill>
+                  <a:srgbClr val="1A1A1A"/>
+                </a:solidFill>
+                <a:latin typeface="Calibri"/>
+              </a:rPr>
               <a:t>Closed-book answers 37 of 72 questions. 16% of those answers are supported</a:t>
             </a:r>
           </a:p>
@@ -5074,7 +5090,7 @@
           <p:nvPr/>
         </p:nvGraphicFramePr>
         <p:xfrm>
-          <a:off x="640080" y="3383280"/>
+          <a:off x="640080" y="3767328"/>
           <a:ext cx="10058400" cy="1463040"/>
         </p:xfrm>
         <a:graphic>
@@ -5593,6 +5609,22 @@
                 </a:solidFill>
                 <a:latin typeface="Calibri"/>
               </a:rPr>
+              <a:t>Unverified items, 72-item sample.</a:t>
+            </a:r>
+          </a:p>
+          <a:p>
+            <a:pPr>
+              <a:spcAft>
+                <a:spcPts val="600"/>
+              </a:spcAft>
+            </a:pPr>
+            <a:r>
+              <a:rPr sz="1800" b="0">
+                <a:solidFill>
+                  <a:srgbClr val="1A1A1A"/>
+                </a:solidFill>
+                <a:latin typeface="Calibri"/>
+              </a:rPr>
               <a:t>Fixing retrieval entirely buys 0.193. The 3B generator is losing 0.597.</a:t>
             </a:r>
           </a:p>
@@ -5623,7 +5655,7 @@
           <p:nvPr/>
         </p:nvGraphicFramePr>
         <p:xfrm>
-          <a:off x="640080" y="2231136"/>
+          <a:off x="640080" y="2615184"/>
           <a:ext cx="10058400" cy="1170432"/>
         </p:xfrm>
         <a:graphic>
@@ -6098,7 +6130,7 @@
                 </a:solidFill>
                 <a:latin typeface="Calibri"/>
               </a:rPr>
-              <a:t>A second negative result: answerability</a:t>
+              <a:t>Answerability: which score you threshold matters</a:t>
             </a:r>
           </a:p>
         </p:txBody>
@@ -6137,7 +6169,7 @@
                 </a:solidFill>
                 <a:latin typeface="Calibri"/>
               </a:rPr>
-              <a:t>Retrieval-score thresholds carry no information about answerability here.</a:t>
+              <a:t>Median top retrieval score, verified set:</a:t>
             </a:r>
           </a:p>
           <a:p>
@@ -6153,7 +6185,7 @@
                 </a:solidFill>
                 <a:latin typeface="Calibri"/>
               </a:rPr>
-              <a:t>Unanswerable questions score higher. Precision stays at the 0.20 base rate at</a:t>
+              <a:t>BM25 threshold on test: F1 0.525, all out-of-scope caught — but only</a:t>
             </a:r>
           </a:p>
           <a:p>
@@ -6169,7 +6201,7 @@
                 </a:solidFill>
                 <a:latin typeface="Calibri"/>
               </a:rPr>
-              <a:t>every threshold.</a:t>
+              <a:t>0.522 of near-miss questions. The fused RRF score carries almost nothing:</a:t>
             </a:r>
           </a:p>
           <a:p>
@@ -6185,7 +6217,7 @@
                 </a:solidFill>
                 <a:latin typeface="Calibri"/>
               </a:rPr>
-              <a:t>Why: 55 of 80 unanswerable items are about schemes that ARE in the corpus.</a:t>
+              <a:t>rank fusion discards the magnitudes.</a:t>
             </a:r>
           </a:p>
           <a:p>
@@ -6201,7 +6233,7 @@
                 </a:solidFill>
                 <a:latin typeface="Calibri"/>
               </a:rPr>
-              <a:t>A retrieval threshold detects corpus absence — and answerability is not corpus</a:t>
+              <a:t>Before verification the BM25 medians were reversed (13.55 vs 13.82): questions</a:t>
             </a:r>
           </a:p>
           <a:p>
@@ -6217,7 +6249,7 @@
                 </a:solidFill>
                 <a:latin typeface="Calibri"/>
               </a:rPr>
-              <a:t>absence.</a:t>
+              <a:t>that did not name their scheme retrieved weakly whether or not they were</a:t>
             </a:r>
           </a:p>
           <a:p>
@@ -6233,7 +6265,39 @@
                 </a:solidFill>
                 <a:latin typeface="Calibri"/>
               </a:rPr>
-              <a:t>Four signals, same items. Of 28 answerable questions, how many get answered?</a:t>
+              <a:t>answerable.</a:t>
+            </a:r>
+          </a:p>
+          <a:p>
+            <a:pPr>
+              <a:spcAft>
+                <a:spcPts val="600"/>
+              </a:spcAft>
+            </a:pPr>
+            <a:r>
+              <a:rPr sz="1800" b="0">
+                <a:solidFill>
+                  <a:srgbClr val="1A1A1A"/>
+                </a:solidFill>
+                <a:latin typeface="Calibri"/>
+              </a:rPr>
+              <a:t>Four signals, same items (unverified set, enriched sample). Of 28 answerable</a:t>
+            </a:r>
+          </a:p>
+          <a:p>
+            <a:pPr>
+              <a:spcAft>
+                <a:spcPts val="600"/>
+              </a:spcAft>
+            </a:pPr>
+            <a:r>
+              <a:rPr sz="1800" b="0">
+                <a:solidFill>
+                  <a:srgbClr val="1A1A1A"/>
+                </a:solidFill>
+                <a:latin typeface="Calibri"/>
+              </a:rPr>
+              <a:t>questions, how many get answered?</a:t>
             </a:r>
           </a:p>
         </p:txBody>
@@ -6247,7 +6311,7 @@
           <p:nvPr/>
         </p:nvGraphicFramePr>
         <p:xfrm>
-          <a:off x="640080" y="4151376"/>
+          <a:off x="640080" y="4919472"/>
           <a:ext cx="10058400" cy="2340864"/>
         </p:xfrm>
         <a:graphic>
@@ -6338,7 +6402,7 @@
                           </a:solidFill>
                           <a:latin typeface="Calibri"/>
                         </a:rPr>
-                        <a:t>13.55</a:t>
+                        <a:t>25.47</a:t>
                       </a:r>
                     </a:p>
                   </a:txBody>
@@ -6394,7 +6458,7 @@
                           </a:solidFill>
                           <a:latin typeface="Calibri"/>
                         </a:rPr>
-                        <a:t>0.1424</a:t>
+                        <a:t>0.238</a:t>
                       </a:r>
                     </a:p>
                   </a:txBody>
@@ -6412,7 +6476,7 @@
                           </a:solidFill>
                           <a:latin typeface="Calibri"/>
                         </a:rPr>
-                        <a:t>0.1485</a:t>
+                        <a:t>0.145</a:t>
                       </a:r>
                     </a:p>
                   </a:txBody>
@@ -6432,7 +6496,7 @@
                           </a:solidFill>
                           <a:latin typeface="Calibri"/>
                         </a:rPr>
-                        <a:t>RRF</a:t>
+                        <a:t>RRF (fused)</a:t>
                       </a:r>
                     </a:p>
                   </a:txBody>
@@ -6450,7 +6514,7 @@
                           </a:solidFill>
                           <a:latin typeface="Calibri"/>
                         </a:rPr>
-                        <a:t>0.0327</a:t>
+                        <a:t>0.0328</a:t>
                       </a:r>
                     </a:p>
                   </a:txBody>
@@ -6865,7 +6929,7 @@
                 </a:solidFill>
                 <a:latin typeface="Calibri"/>
               </a:rPr>
-              <a:t>- 400 items, single primary annotator, blind 15% second pass, κ gated at 0.70</a:t>
+              <a:t>- 393 items, verified by a model, not a person; blind second pass κ = 1.000</a:t>
             </a:r>
           </a:p>
           <a:p>
@@ -6881,7 +6945,23 @@
                 </a:solidFill>
                 <a:latin typeface="Calibri"/>
               </a:rPr>
-              <a:t>- Retrieval numbers are [PROBE] pending gold-set verification</a:t>
+              <a:t>is one model agreeing with itself, not the 0.70 inter-annotator gate</a:t>
+            </a:r>
+          </a:p>
+          <a:p>
+            <a:pPr>
+              <a:spcAft>
+                <a:spcPts val="600"/>
+              </a:spcAft>
+            </a:pPr>
+            <a:r>
+              <a:rPr sz="1800" b="0">
+                <a:solidFill>
+                  <a:srgbClr val="1A1A1A"/>
+                </a:solidFill>
+                <a:latin typeface="Calibri"/>
+              </a:rPr>
+              <a:t>- Probe-set numbers kept only where the mechanism was found; results are test split</a:t>
             </a:r>
           </a:p>
           <a:p>
@@ -7064,7 +7144,7 @@
                 </a:solidFill>
                 <a:latin typeface="Calibri"/>
               </a:rPr>
-              <a:t>Fix the arithmetic, not the model: 7× cross-lingual, 6× code-mixed, no</a:t>
+              <a:t>Fix the arithmetic, not the model: cross-lingual 0.274 → 0.685, no</a:t>
             </a:r>
           </a:p>
           <a:p>
@@ -7080,7 +7160,7 @@
                 </a:solidFill>
                 <a:latin typeface="Calibri"/>
               </a:rPr>
-              <a:t>training.</a:t>
+              <a:t>monolingual cost, no training — and no large gain over dense alone.</a:t>
             </a:r>
           </a:p>
           <a:p>
@@ -7854,7 +7934,7 @@
                 </a:solidFill>
                 <a:latin typeface="Calibri"/>
               </a:rPr>
-              <a:t>- 400-item QA set, query-language × evidence-language matrix, 6 cells</a:t>
+              <a:t>- 393-item QA set (313 answerable, 80 unanswerable in 4 classes),</a:t>
             </a:r>
           </a:p>
           <a:p>
@@ -7870,7 +7950,23 @@
                 </a:solidFill>
                 <a:latin typeface="Calibri"/>
               </a:rPr>
-              <a:t>- 80 unanswerable items across 4 classes</a:t>
+              <a:t>query-language × evidence-language matrix, 6 cells; sealed dev 120 / test 273</a:t>
+            </a:r>
+          </a:p>
+          <a:p>
+            <a:pPr>
+              <a:spcAft>
+                <a:spcPts val="600"/>
+              </a:spcAft>
+            </a:pPr>
+            <a:r>
+              <a:rPr sz="1800" b="0">
+                <a:solidFill>
+                  <a:srgbClr val="1A1A1A"/>
+                </a:solidFill>
+                <a:latin typeface="Calibri"/>
+              </a:rPr>
+              <a:t>- Verified by a language model, not a person — disclosed on every report</a:t>
             </a:r>
           </a:p>
           <a:p>
@@ -8252,7 +8348,7 @@
                 </a:solidFill>
                 <a:latin typeface="Calibri"/>
               </a:rPr>
-              <a:t>Recall@5, cross-lingual queries [PROBE]</a:t>
+              <a:t>Recall@5, cross-lingual queries (test split, n = 62)</a:t>
             </a:r>
           </a:p>
           <a:p>
@@ -8364,7 +8460,7 @@
                           </a:solidFill>
                           <a:latin typeface="Calibri"/>
                         </a:rPr>
-                        <a:t>0.125</a:t>
+                        <a:t>0.661</a:t>
                       </a:r>
                     </a:p>
                   </a:txBody>
@@ -8402,7 +8498,7 @@
                           </a:solidFill>
                           <a:latin typeface="Calibri"/>
                         </a:rPr>
-                        <a:t>0.022</a:t>
+                        <a:t>0.274</a:t>
                       </a:r>
                     </a:p>
                   </a:txBody>
@@ -8873,6 +8969,54 @@
               <a:t>- Query-time cost unchanged</a:t>
             </a:r>
           </a:p>
+          <a:p>
+            <a:pPr>
+              <a:spcAft>
+                <a:spcPts val="600"/>
+              </a:spcAft>
+            </a:pPr>
+            <a:r>
+              <a:rPr sz="1800" b="0">
+                <a:solidFill>
+                  <a:srgbClr val="1A1A1A"/>
+                </a:solidFill>
+                <a:latin typeface="Calibri"/>
+              </a:rPr>
+              <a:t>Test split, Recall@5:</a:t>
+            </a:r>
+          </a:p>
+          <a:p>
+            <a:pPr>
+              <a:spcAft>
+                <a:spcPts val="600"/>
+              </a:spcAft>
+            </a:pPr>
+            <a:r>
+              <a:rPr sz="1800" b="0">
+                <a:solidFill>
+                  <a:srgbClr val="1A1A1A"/>
+                </a:solidFill>
+                <a:latin typeface="Calibri"/>
+              </a:rPr>
+              <a:t>vs plain RRF: +0.411 cross-lingual, +0.132 overall (p = 0.0001).</a:t>
+            </a:r>
+          </a:p>
+          <a:p>
+            <a:pPr>
+              <a:spcAft>
+                <a:spcPts val="600"/>
+              </a:spcAft>
+            </a:pPr>
+            <a:r>
+              <a:rPr sz="1800" b="0">
+                <a:solidFill>
+                  <a:srgbClr val="1A1A1A"/>
+                </a:solidFill>
+                <a:latin typeface="Calibri"/>
+              </a:rPr>
+              <a:t>vs dense alone: +0.030 overall (p = 0.052); significant only code-mixed (+0.085, p = 0.004).</a:t>
+            </a:r>
+          </a:p>
         </p:txBody>
       </p:sp>
       <p:graphicFrame>
@@ -8884,7 +9028,7 @@
           <p:nvPr/>
         </p:nvGraphicFramePr>
         <p:xfrm>
-          <a:off x="640080" y="3383280"/>
+          <a:off x="640080" y="4535424"/>
           <a:ext cx="10058400" cy="1463040"/>
         </p:xfrm>
         <a:graphic>
@@ -8966,7 +9110,7 @@
                           </a:solidFill>
                           <a:latin typeface="Calibri"/>
                         </a:rPr>
-                        <a:t>p</a:t>
+                        <a:t>Dense alone</a:t>
                       </a:r>
                     </a:p>
                   </a:txBody>
@@ -9004,7 +9148,7 @@
                           </a:solidFill>
                           <a:latin typeface="Calibri"/>
                         </a:rPr>
-                        <a:t>0.022</a:t>
+                        <a:t>0.274</a:t>
                       </a:r>
                     </a:p>
                   </a:txBody>
@@ -9022,7 +9166,7 @@
                           </a:solidFill>
                           <a:latin typeface="Calibri"/>
                         </a:rPr>
-                        <a:t>0.153</a:t>
+                        <a:t>0.685</a:t>
                       </a:r>
                     </a:p>
                   </a:txBody>
@@ -9040,7 +9184,7 @@
                           </a:solidFill>
                           <a:latin typeface="Calibri"/>
                         </a:rPr>
-                        <a:t>0.0001</a:t>
+                        <a:t>0.661</a:t>
                       </a:r>
                     </a:p>
                   </a:txBody>
@@ -9078,7 +9222,7 @@
                           </a:solidFill>
                           <a:latin typeface="Calibri"/>
                         </a:rPr>
-                        <a:t>0.028</a:t>
+                        <a:t>0.514</a:t>
                       </a:r>
                     </a:p>
                   </a:txBody>
@@ -9096,7 +9240,7 @@
                           </a:solidFill>
                           <a:latin typeface="Calibri"/>
                         </a:rPr>
-                        <a:t>0.173</a:t>
+                        <a:t>0.556</a:t>
                       </a:r>
                     </a:p>
                   </a:txBody>
@@ -9114,7 +9258,7 @@
                           </a:solidFill>
                           <a:latin typeface="Calibri"/>
                         </a:rPr>
-                        <a:t>0.0002</a:t>
+                        <a:t>0.472</a:t>
                       </a:r>
                     </a:p>
                   </a:txBody>
@@ -9152,7 +9296,7 @@
                           </a:solidFill>
                           <a:latin typeface="Calibri"/>
                         </a:rPr>
-                        <a:t>0.712</a:t>
+                        <a:t>0.964</a:t>
                       </a:r>
                     </a:p>
                   </a:txBody>
@@ -9170,7 +9314,7 @@
                           </a:solidFill>
                           <a:latin typeface="Calibri"/>
                         </a:rPr>
-                        <a:t>0.668</a:t>
+                        <a:t>0.964</a:t>
                       </a:r>
                     </a:p>
                   </a:txBody>
@@ -9188,7 +9332,7 @@
                           </a:solidFill>
                           <a:latin typeface="Calibri"/>
                         </a:rPr>
-                        <a:t>0.032</a:t>
+                        <a:t>0.976</a:t>
                       </a:r>
                     </a:p>
                   </a:txBody>
@@ -9226,7 +9370,7 @@
                           </a:solidFill>
                           <a:latin typeface="Calibri"/>
                         </a:rPr>
-                        <a:t>0.483</a:t>
+                        <a:t>0.618</a:t>
                       </a:r>
                     </a:p>
                   </a:txBody>
@@ -9244,7 +9388,7 @@
                           </a:solidFill>
                           <a:latin typeface="Calibri"/>
                         </a:rPr>
-                        <a:t>0.500</a:t>
+                        <a:t>0.750</a:t>
                       </a:r>
                     </a:p>
                   </a:txBody>
@@ -9262,7 +9406,7 @@
                           </a:solidFill>
                           <a:latin typeface="Calibri"/>
                         </a:rPr>
-                        <a:t>0.32</a:t>
+                        <a:t>0.720</a:t>
                       </a:r>
                     </a:p>
                   </a:txBody>
@@ -9364,7 +9508,7 @@
                 </a:solidFill>
                 <a:latin typeface="Calibri"/>
               </a:rPr>
-              <a:t>Report the trade, not the aggregate</a:t>
+              <a:t>What verification changed</a:t>
             </a:r>
           </a:p>
         </p:txBody>
@@ -9403,7 +9547,7 @@
                 </a:solidFill>
                 <a:latin typeface="Calibri"/>
               </a:rPr>
-              <a:t>Overall Recall@5: 0.483 → 0.500, p = 0.32 — indistinguishable from noise.</a:t>
+              <a:t>On 180 synthetic probes the method looked like a trade: +0.131 cross-lingual,</a:t>
             </a:r>
           </a:p>
           <a:p>
@@ -9419,7 +9563,7 @@
                 </a:solidFill>
                 <a:latin typeface="Calibri"/>
               </a:rPr>
-              <a:t>Reporting only the aggregate would hide both the 7× cross-lingual gain</a:t>
+              <a:t>−0.044 monolingual, and +0.133 over dense alone cross-lingually.</a:t>
             </a:r>
           </a:p>
           <a:p>
@@ -9435,7 +9579,7 @@
                 </a:solidFill>
                 <a:latin typeface="Calibri"/>
               </a:rPr>
-              <a:t>and the 0.044 monolingual cost.</a:t>
+              <a:t>On the verified test split: the repair is larger (+0.411), the monolingual</a:t>
             </a:r>
           </a:p>
           <a:p>
@@ -9451,7 +9595,7 @@
                 </a:solidFill>
                 <a:latin typeface="Calibri"/>
               </a:rPr>
-              <a:t>Good trade on this corpus: monolingual was already strong, cross-lingual was</a:t>
+              <a:t>cost is gone, and the gain over dense alone is mostly gone (+0.024</a:t>
             </a:r>
           </a:p>
           <a:p>
@@ -9467,7 +9611,39 @@
                 </a:solidFill>
                 <a:latin typeface="Calibri"/>
               </a:rPr>
-              <a:t>near zero. On a mostly-monolingual deployment it would be a bad one.</a:t>
+              <a:t>cross-lingual, p = 0.62).</a:t>
+            </a:r>
+          </a:p>
+          <a:p>
+            <a:pPr>
+              <a:spcAft>
+                <a:spcPts val="600"/>
+              </a:spcAft>
+            </a:pPr>
+            <a:r>
+              <a:rPr sz="1800" b="0">
+                <a:solidFill>
+                  <a:srgbClr val="1A1A1A"/>
+                </a:solidFill>
+                <a:latin typeface="Calibri"/>
+              </a:rPr>
+              <a:t>Claim what survives: standard fusion does harm across scripts; the fix removes</a:t>
+            </a:r>
+          </a:p>
+          <a:p>
+            <a:pPr>
+              <a:spcAft>
+                <a:spcPts val="600"/>
+              </a:spcAft>
+            </a:pPr>
+            <a:r>
+              <a:rPr sz="1800" b="0">
+                <a:solidFill>
+                  <a:srgbClr val="1A1A1A"/>
+                </a:solidFill>
+                <a:latin typeface="Calibri"/>
+              </a:rPr>
+              <a:t>it. Not: fusion beats a strong dense retriever.</a:t>
             </a:r>
           </a:p>
         </p:txBody>

</xml_diff>

<commit_message>
Add a 6-page IEEE conference version beside the full paper
paper/ieee.md condenses the paper to conference length; build-docx.py --ieee
--pdf writes IndicRAG-QA-IEEE.docx and .pdf (6 pages, 6 tables, 5 figures)
and never touches the full paper, which stays the source of record. Every
number is from the verified test split, and the verification is described as
it happened: by a language model, not a person.

Condensing surfaced four errors in the full paper, fixed here: §II-D still
said retrieval scores carry no answerability signal; Table II gave design
counts (near-miss 30, false premise 15) rather than verified ones (29, 16);
§V-C still called the test split 280 items; and slide 9 credited the +0.133
gain over dense retrieval to the probes, when it came from the unverified set.
</commit_message>
<xml_diff>
--- a/paper/IndicRAG-QA-slides.pptx
+++ b/paper/IndicRAG-QA-slides.pptx
@@ -9611,7 +9611,23 @@
                 </a:solidFill>
                 <a:latin typeface="Calibri"/>
               </a:rPr>
-              <a:t>−0.044 monolingual, and +0.133 over dense alone cross-lingually.</a:t>
+              <a:t>−0.044 monolingual. On the unverified questions it beat dense alone by</a:t>
+            </a:r>
+          </a:p>
+          <a:p>
+            <a:pPr>
+              <a:spcAft>
+                <a:spcPts val="600"/>
+              </a:spcAft>
+            </a:pPr>
+            <a:r>
+              <a:rPr sz="1800" b="0">
+                <a:solidFill>
+                  <a:srgbClr val="1A1A1A"/>
+                </a:solidFill>
+                <a:latin typeface="Calibri"/>
+              </a:rPr>
+              <a:t>+0.133 cross-lingually.</a:t>
             </a:r>
           </a:p>
           <a:p>

</xml_diff>

<commit_message>
Record the author's review of the test split; report who checked what
The author reviewed all 273 test-split items with dataset verify --recheck
and accepted all 273 unchanged. The 120 dev items rest on the two model
passes.

The review tool overwrote each item's notes with 'verified <date>', erasing
the record of the model passes. Accepting now appends to the notes; the 273
reviewed items have their history restored, followed by 'verified
2026-09-24 by Dhruv'.

Report banners now distinguish three cases -- all model-verified, a mix
(with counts), and all person-reviewed after model passes -- and the one-word
label in check-script headers does the same. All reports regenerated from
cache; only banners changed. The paper, IEEE version, slides, README and
PLAN describe the review as it happened: not blind, one person, test split
only, so there is still no inter-annotator agreement figure.
</commit_message>
<xml_diff>
--- a/paper/IndicRAG-QA-slides.pptx
+++ b/paper/IndicRAG-QA-slides.pptx
@@ -6977,7 +6977,7 @@
                 </a:solidFill>
                 <a:latin typeface="Calibri"/>
               </a:rPr>
-              <a:t>- 393 items, verified by a model, not a person; blind second pass κ = 1.000</a:t>
+              <a:t>- 393 items: two model passes, then one person reviewed the test split, not</a:t>
             </a:r>
           </a:p>
           <a:p>
@@ -6993,7 +6993,23 @@
                 </a:solidFill>
                 <a:latin typeface="Calibri"/>
               </a:rPr>
-              <a:t>is one model agreeing with itself, not the 0.70 inter-annotator gate</a:t>
+              <a:t>blind; dev split model-only; blind second pass κ = 1.000 is one model agreeing</a:t>
+            </a:r>
+          </a:p>
+          <a:p>
+            <a:pPr>
+              <a:spcAft>
+                <a:spcPts val="600"/>
+              </a:spcAft>
+            </a:pPr>
+            <a:r>
+              <a:rPr sz="1800" b="0">
+                <a:solidFill>
+                  <a:srgbClr val="1A1A1A"/>
+                </a:solidFill>
+                <a:latin typeface="Calibri"/>
+              </a:rPr>
+              <a:t>with itself, not the 0.70 inter-annotator gate</a:t>
             </a:r>
           </a:p>
           <a:p>
@@ -8014,7 +8030,7 @@
                 </a:solidFill>
                 <a:latin typeface="Calibri"/>
               </a:rPr>
-              <a:t>- Verified by a language model, not a person — disclosed on every report</a:t>
+              <a:t>- Verified in two model passes; test split reviewed by a person (all 273 accepted)</a:t>
             </a:r>
           </a:p>
           <a:p>

</xml_diff>

<commit_message>
Link the live demo from the README, both papers and the slides
indicragqa.vercel.app and the GitHub repository now appear under the
author block of the full and IEEE papers, at the top of the README, and on
the title and closing slides. PDFs, docx and pptx rebuilt.
</commit_message>
<xml_diff>
--- a/paper/IndicRAG-QA-slides.pptx
+++ b/paper/IndicRAG-QA-slides.pptx
@@ -1007,7 +1007,7 @@
           <a:lstStyle/>
           <a:p>
             <a:r>
-              <a:t>Three sentences, then stop.</a:t>
+              <a:t>Three sentences, then stop. Leave the link on screen for questions.</a:t>
             </a:r>
           </a:p>
         </p:txBody>
@@ -4663,6 +4663,22 @@
                 <a:latin typeface="Calibri"/>
               </a:rPr>
               <a:t>IndicRAG-QA · CSET 346 · Bennett University</a:t>
+            </a:r>
+          </a:p>
+          <a:p>
+            <a:pPr>
+              <a:spcAft>
+                <a:spcPts val="600"/>
+              </a:spcAft>
+            </a:pPr>
+            <a:r>
+              <a:rPr sz="2000" b="0">
+                <a:solidFill>
+                  <a:srgbClr val="5A5A5A"/>
+                </a:solidFill>
+                <a:latin typeface="Calibri"/>
+              </a:rPr>
+              <a:t>indicragqa.vercel.app</a:t>
             </a:r>
           </a:p>
         </p:txBody>
@@ -7241,6 +7257,22 @@
                 <a:latin typeface="Calibri"/>
               </a:rPr>
               <a:t>Found by reading 20 cases, not by reading a table.</a:t>
+            </a:r>
+          </a:p>
+          <a:p>
+            <a:pPr>
+              <a:spcAft>
+                <a:spcPts val="600"/>
+              </a:spcAft>
+            </a:pPr>
+            <a:r>
+              <a:rPr sz="1800" b="0">
+                <a:solidFill>
+                  <a:srgbClr val="1A1A1A"/>
+                </a:solidFill>
+                <a:latin typeface="Calibri"/>
+              </a:rPr>
+              <a:t>Try it: indicragqa.vercel.app</a:t>
             </a:r>
           </a:p>
         </p:txBody>

</xml_diff>